<commit_message>
update ahead of class 1
</commit_message>
<xml_diff>
--- a/docs/lectures/in-class_activities/class_1.pptx
+++ b/docs/lectures/in-class_activities/class_1.pptx
@@ -5,7 +5,7 @@
     <p:sldMasterId id="2147483648" r:id="rId1"/>
   </p:sldMasterIdLst>
   <p:notesMasterIdLst>
-    <p:notesMasterId r:id="rId16"/>
+    <p:notesMasterId r:id="rId15"/>
   </p:notesMasterIdLst>
   <p:sldIdLst>
     <p:sldId id="318" r:id="rId2"/>
@@ -15,13 +15,12 @@
     <p:sldId id="686" r:id="rId6"/>
     <p:sldId id="682" r:id="rId7"/>
     <p:sldId id="683" r:id="rId8"/>
-    <p:sldId id="674" r:id="rId9"/>
-    <p:sldId id="471" r:id="rId10"/>
-    <p:sldId id="685" r:id="rId11"/>
-    <p:sldId id="681" r:id="rId12"/>
-    <p:sldId id="672" r:id="rId13"/>
-    <p:sldId id="684" r:id="rId14"/>
-    <p:sldId id="673" r:id="rId15"/>
+    <p:sldId id="471" r:id="rId9"/>
+    <p:sldId id="685" r:id="rId10"/>
+    <p:sldId id="681" r:id="rId11"/>
+    <p:sldId id="672" r:id="rId12"/>
+    <p:sldId id="684" r:id="rId13"/>
+    <p:sldId id="673" r:id="rId14"/>
   </p:sldIdLst>
   <p:sldSz cx="12192000" cy="6858000"/>
   <p:notesSz cx="6858000" cy="9144000"/>
@@ -238,7 +237,7 @@
           <a:p>
             <a:fld id="{1F845F56-4F69-014F-BF17-BBF57342F13A}" type="datetimeFigureOut">
               <a:rPr lang="en-US" smtClean="0"/>
-              <a:t>9/29/25</a:t>
+              <a:t>9/30/26</a:t>
             </a:fld>
             <a:endParaRPr lang="en-US"/>
           </a:p>
@@ -537,14 +536,14 @@
           <a:ln/>
           <a:extLst>
             <a:ext uri="{909E8E84-426E-40dd-AFC4-6F175D3DCCD1}">
-              <a14:hiddenFill xmlns:a14="http://schemas.microsoft.com/office/drawing/2010/main" xmlns="">
+              <a14:hiddenFill xmlns="" xmlns:a14="http://schemas.microsoft.com/office/drawing/2010/main">
                 <a:solidFill>
                   <a:srgbClr val="FFFFFF"/>
                 </a:solidFill>
               </a14:hiddenFill>
             </a:ext>
             <a:ext uri="{91240B29-F687-4f45-9708-019B960494DF}">
-              <a14:hiddenLine xmlns:a14="http://schemas.microsoft.com/office/drawing/2010/main" xmlns="" w="9525">
+              <a14:hiddenLine xmlns="" xmlns:a14="http://schemas.microsoft.com/office/drawing/2010/main" w="9525">
                 <a:solidFill>
                   <a:srgbClr val="000000"/>
                 </a:solidFill>
@@ -704,14 +703,14 @@
           <a:ln/>
           <a:extLst>
             <a:ext uri="{909E8E84-426E-40dd-AFC4-6F175D3DCCD1}">
-              <a14:hiddenFill xmlns:a14="http://schemas.microsoft.com/office/drawing/2010/main" xmlns="">
+              <a14:hiddenFill xmlns="" xmlns:a14="http://schemas.microsoft.com/office/drawing/2010/main">
                 <a:solidFill>
                   <a:srgbClr val="FFFFFF"/>
                 </a:solidFill>
               </a14:hiddenFill>
             </a:ext>
             <a:ext uri="{91240B29-F687-4f45-9708-019B960494DF}">
-              <a14:hiddenLine xmlns:a14="http://schemas.microsoft.com/office/drawing/2010/main" xmlns="" w="9525">
+              <a14:hiddenLine xmlns="" xmlns:a14="http://schemas.microsoft.com/office/drawing/2010/main" w="9525">
                 <a:solidFill>
                   <a:srgbClr val="000000"/>
                 </a:solidFill>
@@ -721,7 +720,7 @@
               </a14:hiddenLine>
             </a:ext>
             <a:ext uri="{FAA26D3D-D897-4be2-8F04-BA451C77F1D7}">
-              <ma14:placeholderFlag xmlns:ma14="http://schemas.microsoft.com/office/mac/drawingml/2011/main" xmlns="" val="1"/>
+              <ma14:placeholderFlag xmlns="" xmlns:ma14="http://schemas.microsoft.com/office/mac/drawingml/2011/main" val="1"/>
             </a:ext>
           </a:extLst>
         </p:spPr>
@@ -825,7 +824,7 @@
           <a:p>
             <a:fld id="{34649269-E026-4E44-9951-397123D7CFB5}" type="slidenum">
               <a:rPr lang="en-US" smtClean="0"/>
-              <a:t>11</a:t>
+              <a:t>10</a:t>
             </a:fld>
             <a:endParaRPr lang="en-US"/>
           </a:p>
@@ -888,26 +887,7 @@
           <a:bodyPr/>
           <a:lstStyle/>
           <a:p>
-            <a:r>
-              <a:rPr lang="en-US" dirty="0"/>
-              <a:t>https://</a:t>
-            </a:r>
-            <a:r>
-              <a:rPr lang="en-US" dirty="0" err="1"/>
-              <a:t>docs.google.com</a:t>
-            </a:r>
-            <a:r>
-              <a:rPr lang="en-US" dirty="0"/>
-              <a:t>/document/d/1Kk92IApqR0dqP8pjU8KjXSjuFePxToeInctn_EKyqx0/</a:t>
-            </a:r>
-            <a:r>
-              <a:rPr lang="en-US" dirty="0" err="1"/>
-              <a:t>edit?usp</a:t>
-            </a:r>
-            <a:r>
-              <a:rPr lang="en-US" dirty="0"/>
-              <a:t>=sharing</a:t>
-            </a:r>
+            <a:endParaRPr lang="en-US" dirty="0"/>
           </a:p>
         </p:txBody>
       </p:sp>
@@ -928,7 +908,7 @@
           <a:p>
             <a:fld id="{34649269-E026-4E44-9951-397123D7CFB5}" type="slidenum">
               <a:rPr lang="en-US" smtClean="0"/>
-              <a:t>12</a:t>
+              <a:t>11</a:t>
             </a:fld>
             <a:endParaRPr lang="en-US"/>
           </a:p>
@@ -1012,7 +992,7 @@
           <a:p>
             <a:fld id="{34649269-E026-4E44-9951-397123D7CFB5}" type="slidenum">
               <a:rPr lang="en-US" smtClean="0"/>
-              <a:t>13</a:t>
+              <a:t>12</a:t>
             </a:fld>
             <a:endParaRPr lang="en-US"/>
           </a:p>
@@ -1063,14 +1043,14 @@
           <a:ln/>
           <a:extLst>
             <a:ext uri="{909E8E84-426E-40dd-AFC4-6F175D3DCCD1}">
-              <a14:hiddenFill xmlns:a14="http://schemas.microsoft.com/office/drawing/2010/main" xmlns="">
+              <a14:hiddenFill xmlns="" xmlns:a14="http://schemas.microsoft.com/office/drawing/2010/main">
                 <a:solidFill>
                   <a:srgbClr val="FFFFFF"/>
                 </a:solidFill>
               </a14:hiddenFill>
             </a:ext>
             <a:ext uri="{91240B29-F687-4f45-9708-019B960494DF}">
-              <a14:hiddenLine xmlns:a14="http://schemas.microsoft.com/office/drawing/2010/main" xmlns="" w="9525">
+              <a14:hiddenLine xmlns="" xmlns:a14="http://schemas.microsoft.com/office/drawing/2010/main" w="9525">
                 <a:solidFill>
                   <a:srgbClr val="000000"/>
                 </a:solidFill>
@@ -1195,7 +1175,7 @@
             <a:fld id="{2C1D408F-3F93-4F43-8A63-5C97F2D4AA7C}" type="slidenum">
               <a:rPr lang="en-US" sz="1200"/>
               <a:pPr/>
-              <a:t>14</a:t>
+              <a:t>13</a:t>
             </a:fld>
             <a:endParaRPr lang="en-US" sz="1200"/>
           </a:p>
@@ -1230,14 +1210,14 @@
           <a:ln/>
           <a:extLst>
             <a:ext uri="{909E8E84-426E-40dd-AFC4-6F175D3DCCD1}">
-              <a14:hiddenFill xmlns:a14="http://schemas.microsoft.com/office/drawing/2010/main" xmlns="">
+              <a14:hiddenFill xmlns="" xmlns:a14="http://schemas.microsoft.com/office/drawing/2010/main">
                 <a:solidFill>
                   <a:srgbClr val="FFFFFF"/>
                 </a:solidFill>
               </a14:hiddenFill>
             </a:ext>
             <a:ext uri="{91240B29-F687-4f45-9708-019B960494DF}">
-              <a14:hiddenLine xmlns:a14="http://schemas.microsoft.com/office/drawing/2010/main" xmlns="" w="9525">
+              <a14:hiddenLine xmlns="" xmlns:a14="http://schemas.microsoft.com/office/drawing/2010/main" w="9525">
                 <a:solidFill>
                   <a:srgbClr val="000000"/>
                 </a:solidFill>
@@ -1247,7 +1227,7 @@
               </a14:hiddenLine>
             </a:ext>
             <a:ext uri="{FAA26D3D-D897-4be2-8F04-BA451C77F1D7}">
-              <ma14:placeholderFlag xmlns:ma14="http://schemas.microsoft.com/office/mac/drawingml/2011/main" xmlns="" val="1"/>
+              <ma14:placeholderFlag xmlns="" xmlns:ma14="http://schemas.microsoft.com/office/mac/drawingml/2011/main" val="1"/>
             </a:ext>
           </a:extLst>
         </p:spPr>
@@ -1307,14 +1287,14 @@
           <a:ln/>
           <a:extLst>
             <a:ext uri="{909E8E84-426E-40dd-AFC4-6F175D3DCCD1}">
-              <a14:hiddenFill xmlns:a14="http://schemas.microsoft.com/office/drawing/2010/main" xmlns="">
+              <a14:hiddenFill xmlns="" xmlns:a14="http://schemas.microsoft.com/office/drawing/2010/main">
                 <a:solidFill>
                   <a:srgbClr val="FFFFFF"/>
                 </a:solidFill>
               </a14:hiddenFill>
             </a:ext>
             <a:ext uri="{91240B29-F687-4f45-9708-019B960494DF}">
-              <a14:hiddenLine xmlns:a14="http://schemas.microsoft.com/office/drawing/2010/main" xmlns="" w="9525">
+              <a14:hiddenLine xmlns="" xmlns:a14="http://schemas.microsoft.com/office/drawing/2010/main" w="9525">
                 <a:solidFill>
                   <a:srgbClr val="000000"/>
                 </a:solidFill>
@@ -1474,14 +1454,14 @@
           <a:ln/>
           <a:extLst>
             <a:ext uri="{909E8E84-426E-40dd-AFC4-6F175D3DCCD1}">
-              <a14:hiddenFill xmlns:a14="http://schemas.microsoft.com/office/drawing/2010/main" xmlns="">
+              <a14:hiddenFill xmlns="" xmlns:a14="http://schemas.microsoft.com/office/drawing/2010/main">
                 <a:solidFill>
                   <a:srgbClr val="FFFFFF"/>
                 </a:solidFill>
               </a14:hiddenFill>
             </a:ext>
             <a:ext uri="{91240B29-F687-4f45-9708-019B960494DF}">
-              <a14:hiddenLine xmlns:a14="http://schemas.microsoft.com/office/drawing/2010/main" xmlns="" w="9525">
+              <a14:hiddenLine xmlns="" xmlns:a14="http://schemas.microsoft.com/office/drawing/2010/main" w="9525">
                 <a:solidFill>
                   <a:srgbClr val="000000"/>
                 </a:solidFill>
@@ -1491,7 +1471,7 @@
               </a14:hiddenLine>
             </a:ext>
             <a:ext uri="{FAA26D3D-D897-4be2-8F04-BA451C77F1D7}">
-              <ma14:placeholderFlag xmlns:ma14="http://schemas.microsoft.com/office/mac/drawingml/2011/main" xmlns="" val="1"/>
+              <ma14:placeholderFlag xmlns="" xmlns:ma14="http://schemas.microsoft.com/office/mac/drawingml/2011/main" val="1"/>
             </a:ext>
           </a:extLst>
         </p:spPr>
@@ -1608,6 +1588,90 @@
   <p:cSld>
     <p:spTree>
       <p:nvGrpSpPr>
+        <p:cNvPr id="1" name=""/>
+        <p:cNvGrpSpPr/>
+        <p:nvPr/>
+      </p:nvGrpSpPr>
+      <p:grpSpPr>
+        <a:xfrm>
+          <a:off x="0" y="0"/>
+          <a:ext cx="0" cy="0"/>
+          <a:chOff x="0" y="0"/>
+          <a:chExt cx="0" cy="0"/>
+        </a:xfrm>
+      </p:grpSpPr>
+      <p:sp>
+        <p:nvSpPr>
+          <p:cNvPr id="2" name="Slide Image Placeholder 1"/>
+          <p:cNvSpPr>
+            <a:spLocks noGrp="1" noRot="1" noChangeAspect="1"/>
+          </p:cNvSpPr>
+          <p:nvPr>
+            <p:ph type="sldImg"/>
+          </p:nvPr>
+        </p:nvSpPr>
+        <p:spPr/>
+      </p:sp>
+      <p:sp>
+        <p:nvSpPr>
+          <p:cNvPr id="3" name="Notes Placeholder 2"/>
+          <p:cNvSpPr>
+            <a:spLocks noGrp="1"/>
+          </p:cNvSpPr>
+          <p:nvPr>
+            <p:ph type="body" idx="1"/>
+          </p:nvPr>
+        </p:nvSpPr>
+        <p:spPr/>
+        <p:txBody>
+          <a:bodyPr/>
+          <a:lstStyle/>
+          <a:p>
+            <a:endParaRPr lang="en-US"/>
+          </a:p>
+        </p:txBody>
+      </p:sp>
+      <p:sp>
+        <p:nvSpPr>
+          <p:cNvPr id="4" name="Slide Number Placeholder 3"/>
+          <p:cNvSpPr>
+            <a:spLocks noGrp="1"/>
+          </p:cNvSpPr>
+          <p:nvPr>
+            <p:ph type="sldNum" sz="quarter" idx="5"/>
+          </p:nvPr>
+        </p:nvSpPr>
+        <p:spPr/>
+        <p:txBody>
+          <a:bodyPr/>
+          <a:lstStyle/>
+          <a:p>
+            <a:fld id="{34649269-E026-4E44-9951-397123D7CFB5}" type="slidenum">
+              <a:rPr lang="en-US" smtClean="0"/>
+              <a:t>4</a:t>
+            </a:fld>
+            <a:endParaRPr lang="en-US"/>
+          </a:p>
+        </p:txBody>
+      </p:sp>
+    </p:spTree>
+    <p:extLst>
+      <p:ext uri="{BB962C8B-B14F-4D97-AF65-F5344CB8AC3E}">
+        <p14:creationId xmlns:p14="http://schemas.microsoft.com/office/powerpoint/2010/main" val="3280222065"/>
+      </p:ext>
+    </p:extLst>
+  </p:cSld>
+  <p:clrMapOvr>
+    <a:masterClrMapping/>
+  </p:clrMapOvr>
+</p:notes>
+</file>
+
+<file path=ppt/notesSlides/notesSlide5.xml><?xml version="1.0" encoding="utf-8"?>
+<p:notes xmlns:a="http://schemas.openxmlformats.org/drawingml/2006/main" xmlns:r="http://schemas.openxmlformats.org/officeDocument/2006/relationships" xmlns:p="http://schemas.openxmlformats.org/presentationml/2006/main">
+  <p:cSld>
+    <p:spTree>
+      <p:nvGrpSpPr>
         <p:cNvPr id="1" name="">
           <a:extLst>
             <a:ext uri="{FF2B5EF4-FFF2-40B4-BE49-F238E27FC236}">
@@ -1702,90 +1766,6 @@
     <p:extLst>
       <p:ext uri="{BB962C8B-B14F-4D97-AF65-F5344CB8AC3E}">
         <p14:creationId xmlns:p14="http://schemas.microsoft.com/office/powerpoint/2010/main" val="1216782946"/>
-      </p:ext>
-    </p:extLst>
-  </p:cSld>
-  <p:clrMapOvr>
-    <a:masterClrMapping/>
-  </p:clrMapOvr>
-</p:notes>
-</file>
-
-<file path=ppt/notesSlides/notesSlide5.xml><?xml version="1.0" encoding="utf-8"?>
-<p:notes xmlns:a="http://schemas.openxmlformats.org/drawingml/2006/main" xmlns:r="http://schemas.openxmlformats.org/officeDocument/2006/relationships" xmlns:p="http://schemas.openxmlformats.org/presentationml/2006/main">
-  <p:cSld>
-    <p:spTree>
-      <p:nvGrpSpPr>
-        <p:cNvPr id="1" name=""/>
-        <p:cNvGrpSpPr/>
-        <p:nvPr/>
-      </p:nvGrpSpPr>
-      <p:grpSpPr>
-        <a:xfrm>
-          <a:off x="0" y="0"/>
-          <a:ext cx="0" cy="0"/>
-          <a:chOff x="0" y="0"/>
-          <a:chExt cx="0" cy="0"/>
-        </a:xfrm>
-      </p:grpSpPr>
-      <p:sp>
-        <p:nvSpPr>
-          <p:cNvPr id="2" name="Slide Image Placeholder 1"/>
-          <p:cNvSpPr>
-            <a:spLocks noGrp="1" noRot="1" noChangeAspect="1"/>
-          </p:cNvSpPr>
-          <p:nvPr>
-            <p:ph type="sldImg"/>
-          </p:nvPr>
-        </p:nvSpPr>
-        <p:spPr/>
-      </p:sp>
-      <p:sp>
-        <p:nvSpPr>
-          <p:cNvPr id="3" name="Notes Placeholder 2"/>
-          <p:cNvSpPr>
-            <a:spLocks noGrp="1"/>
-          </p:cNvSpPr>
-          <p:nvPr>
-            <p:ph type="body" idx="1"/>
-          </p:nvPr>
-        </p:nvSpPr>
-        <p:spPr/>
-        <p:txBody>
-          <a:bodyPr/>
-          <a:lstStyle/>
-          <a:p>
-            <a:endParaRPr lang="en-US"/>
-          </a:p>
-        </p:txBody>
-      </p:sp>
-      <p:sp>
-        <p:nvSpPr>
-          <p:cNvPr id="4" name="Slide Number Placeholder 3"/>
-          <p:cNvSpPr>
-            <a:spLocks noGrp="1"/>
-          </p:cNvSpPr>
-          <p:nvPr>
-            <p:ph type="sldNum" sz="quarter" idx="5"/>
-          </p:nvPr>
-        </p:nvSpPr>
-        <p:spPr/>
-        <p:txBody>
-          <a:bodyPr/>
-          <a:lstStyle/>
-          <a:p>
-            <a:fld id="{34649269-E026-4E44-9951-397123D7CFB5}" type="slidenum">
-              <a:rPr lang="en-US" smtClean="0"/>
-              <a:t>6</a:t>
-            </a:fld>
-            <a:endParaRPr lang="en-US"/>
-          </a:p>
-        </p:txBody>
-      </p:sp>
-    </p:spTree>
-    <p:extLst>
-      <p:ext uri="{BB962C8B-B14F-4D97-AF65-F5344CB8AC3E}">
-        <p14:creationId xmlns:p14="http://schemas.microsoft.com/office/powerpoint/2010/main" val="2104405"/>
       </p:ext>
     </p:extLst>
   </p:cSld>
@@ -1860,7 +1840,7 @@
           <a:p>
             <a:fld id="{34649269-E026-4E44-9951-397123D7CFB5}" type="slidenum">
               <a:rPr lang="en-US" smtClean="0"/>
-              <a:t>7</a:t>
+              <a:t>6</a:t>
             </a:fld>
             <a:endParaRPr lang="en-US"/>
           </a:p>
@@ -1869,7 +1849,7 @@
     </p:spTree>
     <p:extLst>
       <p:ext uri="{BB962C8B-B14F-4D97-AF65-F5344CB8AC3E}">
-        <p14:creationId xmlns:p14="http://schemas.microsoft.com/office/powerpoint/2010/main" val="51791727"/>
+        <p14:creationId xmlns:p14="http://schemas.microsoft.com/office/powerpoint/2010/main" val="2104405"/>
       </p:ext>
     </p:extLst>
   </p:cSld>
@@ -1898,222 +1878,62 @@
       </p:grpSpPr>
       <p:sp>
         <p:nvSpPr>
-          <p:cNvPr id="18433" name="Rectangle 7"/>
-          <p:cNvSpPr>
-            <a:spLocks noGrp="1" noChangeArrowheads="1"/>
-          </p:cNvSpPr>
-          <p:nvPr>
-            <p:ph type="sldNum" sz="quarter" idx="5"/>
-          </p:nvPr>
-        </p:nvSpPr>
-        <p:spPr>
-          <a:noFill/>
-          <a:ln/>
-          <a:extLst>
-            <a:ext uri="{909E8E84-426E-40dd-AFC4-6F175D3DCCD1}">
-              <a14:hiddenFill xmlns:a14="http://schemas.microsoft.com/office/drawing/2010/main" xmlns="">
-                <a:solidFill>
-                  <a:srgbClr val="FFFFFF"/>
-                </a:solidFill>
-              </a14:hiddenFill>
-            </a:ext>
-            <a:ext uri="{91240B29-F687-4f45-9708-019B960494DF}">
-              <a14:hiddenLine xmlns:a14="http://schemas.microsoft.com/office/drawing/2010/main" xmlns="" w="9525">
-                <a:solidFill>
-                  <a:srgbClr val="000000"/>
-                </a:solidFill>
-                <a:miter lim="800000"/>
-                <a:headEnd/>
-                <a:tailEnd/>
-              </a14:hiddenLine>
-            </a:ext>
-          </a:extLst>
-        </p:spPr>
-        <p:txBody>
-          <a:bodyPr/>
-          <a:lstStyle>
-            <a:lvl1pPr>
-              <a:defRPr sz="2400">
-                <a:solidFill>
-                  <a:schemeClr val="tx1"/>
-                </a:solidFill>
-                <a:latin typeface="Helvetica" charset="0"/>
-                <a:ea typeface="ＭＳ Ｐゴシック" charset="0"/>
-                <a:cs typeface="ＭＳ Ｐゴシック" charset="0"/>
-              </a:defRPr>
-            </a:lvl1pPr>
-            <a:lvl2pPr marL="742950" indent="-285750">
-              <a:defRPr sz="2400">
-                <a:solidFill>
-                  <a:schemeClr val="tx1"/>
-                </a:solidFill>
-                <a:latin typeface="Helvetica" charset="0"/>
-                <a:ea typeface="ＭＳ Ｐゴシック" charset="0"/>
-              </a:defRPr>
-            </a:lvl2pPr>
-            <a:lvl3pPr marL="1143000" indent="-228600">
-              <a:defRPr sz="2400">
-                <a:solidFill>
-                  <a:schemeClr val="tx1"/>
-                </a:solidFill>
-                <a:latin typeface="Helvetica" charset="0"/>
-                <a:ea typeface="ＭＳ Ｐゴシック" charset="0"/>
-              </a:defRPr>
-            </a:lvl3pPr>
-            <a:lvl4pPr marL="1600200" indent="-228600">
-              <a:defRPr sz="2400">
-                <a:solidFill>
-                  <a:schemeClr val="tx1"/>
-                </a:solidFill>
-                <a:latin typeface="Helvetica" charset="0"/>
-                <a:ea typeface="ＭＳ Ｐゴシック" charset="0"/>
-              </a:defRPr>
-            </a:lvl4pPr>
-            <a:lvl5pPr marL="2057400" indent="-228600">
-              <a:defRPr sz="2400">
-                <a:solidFill>
-                  <a:schemeClr val="tx1"/>
-                </a:solidFill>
-                <a:latin typeface="Helvetica" charset="0"/>
-                <a:ea typeface="ＭＳ Ｐゴシック" charset="0"/>
-              </a:defRPr>
-            </a:lvl5pPr>
-            <a:lvl6pPr marL="2514600" indent="-228600" eaLnBrk="0" fontAlgn="base" hangingPunct="0">
-              <a:spcBef>
-                <a:spcPct val="0"/>
-              </a:spcBef>
-              <a:spcAft>
-                <a:spcPct val="0"/>
-              </a:spcAft>
-              <a:defRPr sz="2400">
-                <a:solidFill>
-                  <a:schemeClr val="tx1"/>
-                </a:solidFill>
-                <a:latin typeface="Helvetica" charset="0"/>
-                <a:ea typeface="ＭＳ Ｐゴシック" charset="0"/>
-              </a:defRPr>
-            </a:lvl6pPr>
-            <a:lvl7pPr marL="2971800" indent="-228600" eaLnBrk="0" fontAlgn="base" hangingPunct="0">
-              <a:spcBef>
-                <a:spcPct val="0"/>
-              </a:spcBef>
-              <a:spcAft>
-                <a:spcPct val="0"/>
-              </a:spcAft>
-              <a:defRPr sz="2400">
-                <a:solidFill>
-                  <a:schemeClr val="tx1"/>
-                </a:solidFill>
-                <a:latin typeface="Helvetica" charset="0"/>
-                <a:ea typeface="ＭＳ Ｐゴシック" charset="0"/>
-              </a:defRPr>
-            </a:lvl7pPr>
-            <a:lvl8pPr marL="3429000" indent="-228600" eaLnBrk="0" fontAlgn="base" hangingPunct="0">
-              <a:spcBef>
-                <a:spcPct val="0"/>
-              </a:spcBef>
-              <a:spcAft>
-                <a:spcPct val="0"/>
-              </a:spcAft>
-              <a:defRPr sz="2400">
-                <a:solidFill>
-                  <a:schemeClr val="tx1"/>
-                </a:solidFill>
-                <a:latin typeface="Helvetica" charset="0"/>
-                <a:ea typeface="ＭＳ Ｐゴシック" charset="0"/>
-              </a:defRPr>
-            </a:lvl8pPr>
-            <a:lvl9pPr marL="3886200" indent="-228600" eaLnBrk="0" fontAlgn="base" hangingPunct="0">
-              <a:spcBef>
-                <a:spcPct val="0"/>
-              </a:spcBef>
-              <a:spcAft>
-                <a:spcPct val="0"/>
-              </a:spcAft>
-              <a:defRPr sz="2400">
-                <a:solidFill>
-                  <a:schemeClr val="tx1"/>
-                </a:solidFill>
-                <a:latin typeface="Helvetica" charset="0"/>
-                <a:ea typeface="ＭＳ Ｐゴシック" charset="0"/>
-              </a:defRPr>
-            </a:lvl9pPr>
-          </a:lstStyle>
-          <a:p>
-            <a:fld id="{6101AC86-C8CA-1847-A97E-2A060189EE9C}" type="slidenum">
-              <a:rPr lang="en-US" sz="1200"/>
-              <a:pPr/>
-              <a:t>8</a:t>
-            </a:fld>
-            <a:endParaRPr lang="en-US" sz="1200"/>
-          </a:p>
-        </p:txBody>
-      </p:sp>
-      <p:sp>
-        <p:nvSpPr>
-          <p:cNvPr id="18434" name="Rectangle 2"/>
-          <p:cNvSpPr>
-            <a:spLocks noGrp="1" noRot="1" noChangeAspect="1" noChangeArrowheads="1" noTextEdit="1"/>
+          <p:cNvPr id="2" name="Slide Image Placeholder 1"/>
+          <p:cNvSpPr>
+            <a:spLocks noGrp="1" noRot="1" noChangeAspect="1"/>
           </p:cNvSpPr>
           <p:nvPr>
             <p:ph type="sldImg"/>
           </p:nvPr>
         </p:nvSpPr>
-        <p:spPr>
-          <a:ln/>
-        </p:spPr>
-      </p:sp>
-      <p:sp>
-        <p:nvSpPr>
-          <p:cNvPr id="18435" name="Rectangle 3"/>
-          <p:cNvSpPr>
-            <a:spLocks noGrp="1" noChangeArrowheads="1"/>
+        <p:spPr/>
+      </p:sp>
+      <p:sp>
+        <p:nvSpPr>
+          <p:cNvPr id="3" name="Notes Placeholder 2"/>
+          <p:cNvSpPr>
+            <a:spLocks noGrp="1"/>
           </p:cNvSpPr>
           <p:nvPr>
             <p:ph type="body" idx="1"/>
           </p:nvPr>
         </p:nvSpPr>
-        <p:spPr>
-          <a:noFill/>
-          <a:ln/>
-          <a:extLst>
-            <a:ext uri="{909E8E84-426E-40dd-AFC4-6F175D3DCCD1}">
-              <a14:hiddenFill xmlns:a14="http://schemas.microsoft.com/office/drawing/2010/main" xmlns="">
-                <a:solidFill>
-                  <a:srgbClr val="FFFFFF"/>
-                </a:solidFill>
-              </a14:hiddenFill>
-            </a:ext>
-            <a:ext uri="{91240B29-F687-4f45-9708-019B960494DF}">
-              <a14:hiddenLine xmlns:a14="http://schemas.microsoft.com/office/drawing/2010/main" xmlns="" w="9525">
-                <a:solidFill>
-                  <a:srgbClr val="000000"/>
-                </a:solidFill>
-                <a:miter lim="800000"/>
-                <a:headEnd/>
-                <a:tailEnd/>
-              </a14:hiddenLine>
-            </a:ext>
-            <a:ext uri="{FAA26D3D-D897-4be2-8F04-BA451C77F1D7}">
-              <ma14:placeholderFlag xmlns:ma14="http://schemas.microsoft.com/office/mac/drawingml/2011/main" xmlns="" val="1"/>
-            </a:ext>
-          </a:extLst>
-        </p:spPr>
+        <p:spPr/>
         <p:txBody>
           <a:bodyPr/>
           <a:lstStyle/>
           <a:p>
-            <a:pPr eaLnBrk="1" hangingPunct="1"/>
-            <a:endParaRPr lang="en-US">
-              <a:latin typeface="Times" charset="0"/>
-            </a:endParaRPr>
+            <a:endParaRPr lang="en-US"/>
+          </a:p>
+        </p:txBody>
+      </p:sp>
+      <p:sp>
+        <p:nvSpPr>
+          <p:cNvPr id="4" name="Slide Number Placeholder 3"/>
+          <p:cNvSpPr>
+            <a:spLocks noGrp="1"/>
+          </p:cNvSpPr>
+          <p:nvPr>
+            <p:ph type="sldNum" sz="quarter" idx="5"/>
+          </p:nvPr>
+        </p:nvSpPr>
+        <p:spPr/>
+        <p:txBody>
+          <a:bodyPr/>
+          <a:lstStyle/>
+          <a:p>
+            <a:fld id="{34649269-E026-4E44-9951-397123D7CFB5}" type="slidenum">
+              <a:rPr lang="en-US" smtClean="0"/>
+              <a:t>7</a:t>
+            </a:fld>
+            <a:endParaRPr lang="en-US"/>
           </a:p>
         </p:txBody>
       </p:sp>
     </p:spTree>
     <p:extLst>
       <p:ext uri="{BB962C8B-B14F-4D97-AF65-F5344CB8AC3E}">
-        <p14:creationId xmlns:p14="http://schemas.microsoft.com/office/powerpoint/2010/main" val="1694909980"/>
+        <p14:creationId xmlns:p14="http://schemas.microsoft.com/office/powerpoint/2010/main" val="51791727"/>
       </p:ext>
     </p:extLst>
   </p:cSld>
@@ -2155,14 +1975,14 @@
           <a:ln/>
           <a:extLst>
             <a:ext uri="{909E8E84-426E-40dd-AFC4-6F175D3DCCD1}">
-              <a14:hiddenFill xmlns:a14="http://schemas.microsoft.com/office/drawing/2010/main" xmlns="">
+              <a14:hiddenFill xmlns="" xmlns:a14="http://schemas.microsoft.com/office/drawing/2010/main">
                 <a:solidFill>
                   <a:srgbClr val="FFFFFF"/>
                 </a:solidFill>
               </a14:hiddenFill>
             </a:ext>
             <a:ext uri="{91240B29-F687-4f45-9708-019B960494DF}">
-              <a14:hiddenLine xmlns:a14="http://schemas.microsoft.com/office/drawing/2010/main" xmlns="" w="9525">
+              <a14:hiddenLine xmlns="" xmlns:a14="http://schemas.microsoft.com/office/drawing/2010/main" w="9525">
                 <a:solidFill>
                   <a:srgbClr val="000000"/>
                 </a:solidFill>
@@ -2287,7 +2107,7 @@
             <a:fld id="{2C1D408F-3F93-4F43-8A63-5C97F2D4AA7C}" type="slidenum">
               <a:rPr lang="en-US" sz="1200"/>
               <a:pPr/>
-              <a:t>9</a:t>
+              <a:t>8</a:t>
             </a:fld>
             <a:endParaRPr lang="en-US" sz="1200"/>
           </a:p>
@@ -2322,14 +2142,14 @@
           <a:ln/>
           <a:extLst>
             <a:ext uri="{909E8E84-426E-40dd-AFC4-6F175D3DCCD1}">
-              <a14:hiddenFill xmlns:a14="http://schemas.microsoft.com/office/drawing/2010/main" xmlns="">
+              <a14:hiddenFill xmlns="" xmlns:a14="http://schemas.microsoft.com/office/drawing/2010/main">
                 <a:solidFill>
                   <a:srgbClr val="FFFFFF"/>
                 </a:solidFill>
               </a14:hiddenFill>
             </a:ext>
             <a:ext uri="{91240B29-F687-4f45-9708-019B960494DF}">
-              <a14:hiddenLine xmlns:a14="http://schemas.microsoft.com/office/drawing/2010/main" xmlns="" w="9525">
+              <a14:hiddenLine xmlns="" xmlns:a14="http://schemas.microsoft.com/office/drawing/2010/main" w="9525">
                 <a:solidFill>
                   <a:srgbClr val="000000"/>
                 </a:solidFill>
@@ -2339,7 +2159,7 @@
               </a14:hiddenLine>
             </a:ext>
             <a:ext uri="{FAA26D3D-D897-4be2-8F04-BA451C77F1D7}">
-              <ma14:placeholderFlag xmlns:ma14="http://schemas.microsoft.com/office/mac/drawingml/2011/main" xmlns="" val="1"/>
+              <ma14:placeholderFlag xmlns="" xmlns:ma14="http://schemas.microsoft.com/office/mac/drawingml/2011/main" val="1"/>
             </a:ext>
           </a:extLst>
         </p:spPr>
@@ -2443,7 +2263,7 @@
           <a:p>
             <a:fld id="{34649269-E026-4E44-9951-397123D7CFB5}" type="slidenum">
               <a:rPr lang="en-US" smtClean="0"/>
-              <a:t>10</a:t>
+              <a:t>9</a:t>
             </a:fld>
             <a:endParaRPr lang="en-US"/>
           </a:p>
@@ -2609,7 +2429,7 @@
           <a:p>
             <a:fld id="{F479D3E4-8685-A449-A498-91BE67604F63}" type="datetimeFigureOut">
               <a:rPr lang="en-US" smtClean="0"/>
-              <a:t>9/29/25</a:t>
+              <a:t>9/30/26</a:t>
             </a:fld>
             <a:endParaRPr lang="en-US"/>
           </a:p>
@@ -2807,7 +2627,7 @@
           <a:p>
             <a:fld id="{F479D3E4-8685-A449-A498-91BE67604F63}" type="datetimeFigureOut">
               <a:rPr lang="en-US" smtClean="0"/>
-              <a:t>9/29/25</a:t>
+              <a:t>9/30/26</a:t>
             </a:fld>
             <a:endParaRPr lang="en-US"/>
           </a:p>
@@ -3015,7 +2835,7 @@
           <a:p>
             <a:fld id="{F479D3E4-8685-A449-A498-91BE67604F63}" type="datetimeFigureOut">
               <a:rPr lang="en-US" smtClean="0"/>
-              <a:t>9/29/25</a:t>
+              <a:t>9/30/26</a:t>
             </a:fld>
             <a:endParaRPr lang="en-US"/>
           </a:p>
@@ -3213,7 +3033,7 @@
           <a:p>
             <a:fld id="{F479D3E4-8685-A449-A498-91BE67604F63}" type="datetimeFigureOut">
               <a:rPr lang="en-US" smtClean="0"/>
-              <a:t>9/29/25</a:t>
+              <a:t>9/30/26</a:t>
             </a:fld>
             <a:endParaRPr lang="en-US"/>
           </a:p>
@@ -3488,7 +3308,7 @@
           <a:p>
             <a:fld id="{F479D3E4-8685-A449-A498-91BE67604F63}" type="datetimeFigureOut">
               <a:rPr lang="en-US" smtClean="0"/>
-              <a:t>9/29/25</a:t>
+              <a:t>9/30/26</a:t>
             </a:fld>
             <a:endParaRPr lang="en-US"/>
           </a:p>
@@ -3753,7 +3573,7 @@
           <a:p>
             <a:fld id="{F479D3E4-8685-A449-A498-91BE67604F63}" type="datetimeFigureOut">
               <a:rPr lang="en-US" smtClean="0"/>
-              <a:t>9/29/25</a:t>
+              <a:t>9/30/26</a:t>
             </a:fld>
             <a:endParaRPr lang="en-US"/>
           </a:p>
@@ -4165,7 +3985,7 @@
           <a:p>
             <a:fld id="{F479D3E4-8685-A449-A498-91BE67604F63}" type="datetimeFigureOut">
               <a:rPr lang="en-US" smtClean="0"/>
-              <a:t>9/29/25</a:t>
+              <a:t>9/30/26</a:t>
             </a:fld>
             <a:endParaRPr lang="en-US"/>
           </a:p>
@@ -4306,7 +4126,7 @@
           <a:p>
             <a:fld id="{F479D3E4-8685-A449-A498-91BE67604F63}" type="datetimeFigureOut">
               <a:rPr lang="en-US" smtClean="0"/>
-              <a:t>9/29/25</a:t>
+              <a:t>9/30/26</a:t>
             </a:fld>
             <a:endParaRPr lang="en-US"/>
           </a:p>
@@ -4419,7 +4239,7 @@
           <a:p>
             <a:fld id="{F479D3E4-8685-A449-A498-91BE67604F63}" type="datetimeFigureOut">
               <a:rPr lang="en-US" smtClean="0"/>
-              <a:t>9/29/25</a:t>
+              <a:t>9/30/26</a:t>
             </a:fld>
             <a:endParaRPr lang="en-US"/>
           </a:p>
@@ -4730,7 +4550,7 @@
           <a:p>
             <a:fld id="{F479D3E4-8685-A449-A498-91BE67604F63}" type="datetimeFigureOut">
               <a:rPr lang="en-US" smtClean="0"/>
-              <a:t>9/29/25</a:t>
+              <a:t>9/30/26</a:t>
             </a:fld>
             <a:endParaRPr lang="en-US"/>
           </a:p>
@@ -5018,7 +4838,7 @@
           <a:p>
             <a:fld id="{F479D3E4-8685-A449-A498-91BE67604F63}" type="datetimeFigureOut">
               <a:rPr lang="en-US" smtClean="0"/>
-              <a:t>9/29/25</a:t>
+              <a:t>9/30/26</a:t>
             </a:fld>
             <a:endParaRPr lang="en-US"/>
           </a:p>
@@ -5259,7 +5079,7 @@
           <a:p>
             <a:fld id="{F479D3E4-8685-A449-A498-91BE67604F63}" type="datetimeFigureOut">
               <a:rPr lang="en-US" smtClean="0"/>
-              <a:t>9/29/25</a:t>
+              <a:t>9/30/26</a:t>
             </a:fld>
             <a:endParaRPr lang="en-US"/>
           </a:p>
@@ -5706,14 +5526,14 @@
           </a:ln>
           <a:extLst>
             <a:ext uri="{909E8E84-426E-40dd-AFC4-6F175D3DCCD1}">
-              <a14:hiddenFill xmlns="" xmlns:a14="http://schemas.microsoft.com/office/drawing/2010/main">
+              <a14:hiddenFill xmlns:a14="http://schemas.microsoft.com/office/drawing/2010/main" xmlns="">
                 <a:solidFill>
                   <a:srgbClr val="FFFFFF"/>
                 </a:solidFill>
               </a14:hiddenFill>
             </a:ext>
             <a:ext uri="{91240B29-F687-4f45-9708-019B960494DF}">
-              <a14:hiddenLine xmlns="" xmlns:a14="http://schemas.microsoft.com/office/drawing/2010/main" w="9525">
+              <a14:hiddenLine xmlns:a14="http://schemas.microsoft.com/office/drawing/2010/main" xmlns="" w="9525">
                 <a:solidFill>
                   <a:srgbClr val="000000"/>
                 </a:solidFill>
@@ -5889,14 +5709,14 @@
           </a:ln>
           <a:extLst>
             <a:ext uri="{909E8E84-426E-40dd-AFC4-6F175D3DCCD1}">
-              <a14:hiddenFill xmlns="" xmlns:a14="http://schemas.microsoft.com/office/drawing/2010/main">
+              <a14:hiddenFill xmlns:a14="http://schemas.microsoft.com/office/drawing/2010/main" xmlns="">
                 <a:solidFill>
                   <a:srgbClr val="FFFFFF"/>
                 </a:solidFill>
               </a14:hiddenFill>
             </a:ext>
             <a:ext uri="{91240B29-F687-4f45-9708-019B960494DF}">
-              <a14:hiddenLine xmlns="" xmlns:a14="http://schemas.microsoft.com/office/drawing/2010/main" w="9525">
+              <a14:hiddenLine xmlns:a14="http://schemas.microsoft.com/office/drawing/2010/main" xmlns="" w="9525">
                 <a:solidFill>
                   <a:srgbClr val="000000"/>
                 </a:solidFill>
@@ -5930,14 +5750,14 @@
           </a:ln>
           <a:extLst>
             <a:ext uri="{909E8E84-426E-40dd-AFC4-6F175D3DCCD1}">
-              <a14:hiddenFill xmlns="" xmlns:a14="http://schemas.microsoft.com/office/drawing/2010/main">
+              <a14:hiddenFill xmlns:a14="http://schemas.microsoft.com/office/drawing/2010/main" xmlns="">
                 <a:solidFill>
                   <a:srgbClr val="FFFFFF"/>
                 </a:solidFill>
               </a14:hiddenFill>
             </a:ext>
             <a:ext uri="{91240B29-F687-4f45-9708-019B960494DF}">
-              <a14:hiddenLine xmlns="" xmlns:a14="http://schemas.microsoft.com/office/drawing/2010/main" w="9525">
+              <a14:hiddenLine xmlns:a14="http://schemas.microsoft.com/office/drawing/2010/main" xmlns="" w="9525">
                 <a:solidFill>
                   <a:srgbClr val="000000"/>
                 </a:solidFill>
@@ -6008,116 +5828,6 @@
 </file>
 
 <file path=ppt/slides/slide10.xml><?xml version="1.0" encoding="utf-8"?>
-<p:sld xmlns:a="http://schemas.openxmlformats.org/drawingml/2006/main" xmlns:r="http://schemas.openxmlformats.org/officeDocument/2006/relationships" xmlns:p="http://schemas.openxmlformats.org/presentationml/2006/main">
-  <p:cSld>
-    <p:spTree>
-      <p:nvGrpSpPr>
-        <p:cNvPr id="1" name=""/>
-        <p:cNvGrpSpPr/>
-        <p:nvPr/>
-      </p:nvGrpSpPr>
-      <p:grpSpPr>
-        <a:xfrm>
-          <a:off x="0" y="0"/>
-          <a:ext cx="0" cy="0"/>
-          <a:chOff x="0" y="0"/>
-          <a:chExt cx="0" cy="0"/>
-        </a:xfrm>
-      </p:grpSpPr>
-      <p:sp>
-        <p:nvSpPr>
-          <p:cNvPr id="2" name="Title 1">
-            <a:extLst>
-              <a:ext uri="{FF2B5EF4-FFF2-40B4-BE49-F238E27FC236}">
-                <a16:creationId xmlns:a16="http://schemas.microsoft.com/office/drawing/2014/main" id="{D46328C8-E57A-4548-E685-7C8547826A9D}"/>
-              </a:ext>
-            </a:extLst>
-          </p:cNvPr>
-          <p:cNvSpPr>
-            <a:spLocks noGrp="1"/>
-          </p:cNvSpPr>
-          <p:nvPr>
-            <p:ph type="ctrTitle"/>
-          </p:nvPr>
-        </p:nvSpPr>
-        <p:spPr/>
-        <p:txBody>
-          <a:bodyPr/>
-          <a:lstStyle/>
-          <a:p>
-            <a:endParaRPr lang="en-US"/>
-          </a:p>
-        </p:txBody>
-      </p:sp>
-      <p:sp>
-        <p:nvSpPr>
-          <p:cNvPr id="3" name="Subtitle 2">
-            <a:extLst>
-              <a:ext uri="{FF2B5EF4-FFF2-40B4-BE49-F238E27FC236}">
-                <a16:creationId xmlns:a16="http://schemas.microsoft.com/office/drawing/2014/main" id="{45A1BAE9-70C8-C269-8AD4-7B4B3D134C13}"/>
-              </a:ext>
-            </a:extLst>
-          </p:cNvPr>
-          <p:cNvSpPr>
-            <a:spLocks noGrp="1"/>
-          </p:cNvSpPr>
-          <p:nvPr>
-            <p:ph type="subTitle" idx="1"/>
-          </p:nvPr>
-        </p:nvSpPr>
-        <p:spPr/>
-        <p:txBody>
-          <a:bodyPr/>
-          <a:lstStyle/>
-          <a:p>
-            <a:endParaRPr lang="en-US"/>
-          </a:p>
-        </p:txBody>
-      </p:sp>
-      <p:pic>
-        <p:nvPicPr>
-          <p:cNvPr id="5" name="slide.url=https://www.polleverywhere.com/multiple_choice_polls/C5Mf4wqoOzxgPhTX3YZyj?state=opened&amp;flow=Default&amp;onscreen=persist">
-            <a:extLst>
-              <a:ext uri="{FF2B5EF4-FFF2-40B4-BE49-F238E27FC236}">
-                <a16:creationId xmlns:a16="http://schemas.microsoft.com/office/drawing/2014/main" id="{C1680DC4-93E8-614B-054E-9D7DCD24A5C6}"/>
-              </a:ext>
-            </a:extLst>
-          </p:cNvPr>
-          <p:cNvPicPr>
-            <a:picLocks/>
-          </p:cNvPicPr>
-          <p:nvPr/>
-        </p:nvPicPr>
-        <p:blipFill>
-          <a:blip r:embed="rId3"/>
-          <a:stretch>
-            <a:fillRect/>
-          </a:stretch>
-        </p:blipFill>
-        <p:spPr>
-          <a:xfrm>
-            <a:off x="63500" y="63500"/>
-            <a:ext cx="12065000" cy="6731000"/>
-          </a:xfrm>
-          <a:prstGeom prst="rect">
-            <a:avLst/>
-          </a:prstGeom>
-        </p:spPr>
-      </p:pic>
-    </p:spTree>
-    <p:extLst>
-      <p:ext uri="{BB962C8B-B14F-4D97-AF65-F5344CB8AC3E}">
-        <p14:creationId xmlns:p14="http://schemas.microsoft.com/office/powerpoint/2010/main" val="1511497431"/>
-      </p:ext>
-    </p:extLst>
-  </p:cSld>
-  <p:clrMapOvr>
-    <a:masterClrMapping/>
-  </p:clrMapOvr>
-</p:sld>
-</file>
-
-<file path=ppt/slides/slide11.xml><?xml version="1.0" encoding="utf-8"?>
 <p:sld xmlns:a="http://schemas.openxmlformats.org/drawingml/2006/main" xmlns:r="http://schemas.openxmlformats.org/officeDocument/2006/relationships" xmlns:p="http://schemas.openxmlformats.org/presentationml/2006/main">
   <p:cSld>
     <p:spTree>
@@ -6227,7 +5937,7 @@
 </p:sld>
 </file>
 
-<file path=ppt/slides/slide12.xml><?xml version="1.0" encoding="utf-8"?>
+<file path=ppt/slides/slide11.xml><?xml version="1.0" encoding="utf-8"?>
 <p:sld xmlns:a="http://schemas.openxmlformats.org/drawingml/2006/main" xmlns:r="http://schemas.openxmlformats.org/officeDocument/2006/relationships" xmlns:p="http://schemas.openxmlformats.org/presentationml/2006/main">
   <p:cSld>
     <p:spTree>
@@ -6489,7 +6199,7 @@
                 <a:latin typeface="Avenir"/>
                 <a:cs typeface="Avenir"/>
               </a:rPr>
-              <a:t>Note-taker (in Google doc)</a:t>
+              <a:t>Note-taker </a:t>
             </a:r>
           </a:p>
           <a:p>
@@ -7092,7 +6802,7 @@
 </p:sld>
 </file>
 
-<file path=ppt/slides/slide13.xml><?xml version="1.0" encoding="utf-8"?>
+<file path=ppt/slides/slide12.xml><?xml version="1.0" encoding="utf-8"?>
 <p:sld xmlns:a="http://schemas.openxmlformats.org/drawingml/2006/main" xmlns:r="http://schemas.openxmlformats.org/officeDocument/2006/relationships" xmlns:p="http://schemas.openxmlformats.org/presentationml/2006/main">
   <p:cSld>
     <p:bg>
@@ -7194,7 +6904,7 @@
 </p:sld>
 </file>
 
-<file path=ppt/slides/slide14.xml><?xml version="1.0" encoding="utf-8"?>
+<file path=ppt/slides/slide13.xml><?xml version="1.0" encoding="utf-8"?>
 <p:sld xmlns:a="http://schemas.openxmlformats.org/drawingml/2006/main" xmlns:r="http://schemas.openxmlformats.org/officeDocument/2006/relationships" xmlns:p="http://schemas.openxmlformats.org/presentationml/2006/main">
   <p:cSld>
     <p:bg>
@@ -7241,14 +6951,14 @@
           </a:ln>
           <a:extLst>
             <a:ext uri="{909E8E84-426E-40dd-AFC4-6F175D3DCCD1}">
-              <a14:hiddenFill xmlns="" xmlns:a14="http://schemas.microsoft.com/office/drawing/2010/main">
+              <a14:hiddenFill xmlns:a14="http://schemas.microsoft.com/office/drawing/2010/main" xmlns="">
                 <a:solidFill>
                   <a:srgbClr val="FFFFFF"/>
                 </a:solidFill>
               </a14:hiddenFill>
             </a:ext>
             <a:ext uri="{91240B29-F687-4f45-9708-019B960494DF}">
-              <a14:hiddenLine xmlns="" xmlns:a14="http://schemas.microsoft.com/office/drawing/2010/main" w="9525">
+              <a14:hiddenLine xmlns:a14="http://schemas.microsoft.com/office/drawing/2010/main" xmlns="" w="9525">
                 <a:solidFill>
                   <a:srgbClr val="000000"/>
                 </a:solidFill>
@@ -7424,14 +7134,14 @@
           </a:ln>
           <a:extLst>
             <a:ext uri="{909E8E84-426E-40dd-AFC4-6F175D3DCCD1}">
-              <a14:hiddenFill xmlns="" xmlns:a14="http://schemas.microsoft.com/office/drawing/2010/main">
+              <a14:hiddenFill xmlns:a14="http://schemas.microsoft.com/office/drawing/2010/main" xmlns="">
                 <a:solidFill>
                   <a:srgbClr val="FFFFFF"/>
                 </a:solidFill>
               </a14:hiddenFill>
             </a:ext>
             <a:ext uri="{91240B29-F687-4f45-9708-019B960494DF}">
-              <a14:hiddenLine xmlns="" xmlns:a14="http://schemas.microsoft.com/office/drawing/2010/main" w="9525">
+              <a14:hiddenLine xmlns:a14="http://schemas.microsoft.com/office/drawing/2010/main" xmlns="" w="9525">
                 <a:solidFill>
                   <a:srgbClr val="000000"/>
                 </a:solidFill>
@@ -7465,14 +7175,14 @@
           </a:ln>
           <a:extLst>
             <a:ext uri="{909E8E84-426E-40dd-AFC4-6F175D3DCCD1}">
-              <a14:hiddenFill xmlns="" xmlns:a14="http://schemas.microsoft.com/office/drawing/2010/main">
+              <a14:hiddenFill xmlns:a14="http://schemas.microsoft.com/office/drawing/2010/main" xmlns="">
                 <a:solidFill>
                   <a:srgbClr val="FFFFFF"/>
                 </a:solidFill>
               </a14:hiddenFill>
             </a:ext>
             <a:ext uri="{91240B29-F687-4f45-9708-019B960494DF}">
-              <a14:hiddenLine xmlns="" xmlns:a14="http://schemas.microsoft.com/office/drawing/2010/main" w="9525">
+              <a14:hiddenLine xmlns:a14="http://schemas.microsoft.com/office/drawing/2010/main" xmlns="" w="9525">
                 <a:solidFill>
                   <a:srgbClr val="000000"/>
                 </a:solidFill>
@@ -7654,7 +7364,7 @@
                 <a:latin typeface="Avenir"/>
                 <a:cs typeface="Avenir"/>
               </a:rPr>
-              <a:t>Autumn 2025</a:t>
+              <a:t>Autumn 2026</a:t>
             </a:r>
           </a:p>
           <a:p>
@@ -7731,7 +7441,7 @@
                 <a:latin typeface="Avenir"/>
                 <a:cs typeface="Avenir"/>
               </a:rPr>
-              <a:t>			Connor Whalen	</a:t>
+              <a:t>			Diana Perales Macedo	</a:t>
             </a:r>
           </a:p>
         </p:txBody>
@@ -7776,11 +7486,11 @@
       </p:grpSpPr>
       <p:pic>
         <p:nvPicPr>
-          <p:cNvPr id="4" name="Online Media 3" descr="Hairworms collected near Lake Okukiso, Japan">
+          <p:cNvPr id="2" name="Online Media 1" descr="Hairworms collected near Lake Okukiso, Japan">
             <a:hlinkClick r:id="" action="ppaction://media"/>
             <a:extLst>
               <a:ext uri="{FF2B5EF4-FFF2-40B4-BE49-F238E27FC236}">
-                <a16:creationId xmlns:a16="http://schemas.microsoft.com/office/drawing/2014/main" id="{740F5142-67C0-A518-2BFD-4F74A86CE0FE}"/>
+                <a16:creationId xmlns:a16="http://schemas.microsoft.com/office/drawing/2014/main" id="{6809B311-987F-D789-ACEF-C91C76B4B1E1}"/>
               </a:ext>
             </a:extLst>
           </p:cNvPr>
@@ -7799,8 +7509,8 @@
         </p:blipFill>
         <p:spPr>
           <a:xfrm>
-            <a:off x="4101192" y="39175"/>
-            <a:ext cx="3852636" cy="6818825"/>
+            <a:off x="3994150" y="35964"/>
+            <a:ext cx="3854450" cy="6822036"/>
           </a:xfrm>
           <a:prstGeom prst="rect">
             <a:avLst/>
@@ -7850,7 +7560,7 @@
                                       <p:cBhvr>
                                         <p:cTn id="6" dur="1" fill="hold"/>
                                         <p:tgtEl>
-                                          <p:spTgt spid="4"/>
+                                          <p:spTgt spid="2"/>
                                         </p:tgtEl>
                                       </p:cBhvr>
                                     </p:cmd>
@@ -7888,7 +7598,7 @@
                   </p:stCondLst>
                 </p:cTn>
                 <p:tgtEl>
-                  <p:spTgt spid="4"/>
+                  <p:spTgt spid="2"/>
                 </p:tgtEl>
               </p:cMediaNode>
             </p:video>
@@ -7897,7 +7607,7 @@
                 <p:stCondLst>
                   <p:cond evt="onClick" delay="0">
                     <p:tgtEl>
-                      <p:spTgt spid="4"/>
+                      <p:spTgt spid="2"/>
                     </p:tgtEl>
                   </p:cond>
                 </p:stCondLst>
@@ -7927,7 +7637,7 @@
                                       <p:cBhvr>
                                         <p:cTn id="12" dur="1" fill="hold"/>
                                         <p:tgtEl>
-                                          <p:spTgt spid="4"/>
+                                          <p:spTgt spid="2"/>
                                         </p:tgtEl>
                                       </p:cBhvr>
                                     </p:cmd>
@@ -7945,7 +7655,7 @@
               <p:nextCondLst>
                 <p:cond evt="onClick" delay="0">
                   <p:tgtEl>
-                    <p:spTgt spid="4"/>
+                    <p:spTgt spid="2"/>
                   </p:tgtEl>
                 </p:cond>
               </p:nextCondLst>
@@ -7990,7 +7700,7 @@
           <p:nvPr/>
         </p:nvPicPr>
         <p:blipFill>
-          <a:blip r:embed="rId2"/>
+          <a:blip r:embed="rId3"/>
           <a:stretch>
             <a:fillRect/>
           </a:stretch>
@@ -8479,217 +8189,6 @@
       </p:grpSpPr>
       <p:sp>
         <p:nvSpPr>
-          <p:cNvPr id="2050" name="Rectangle 2"/>
-          <p:cNvSpPr>
-            <a:spLocks noChangeArrowheads="1"/>
-          </p:cNvSpPr>
-          <p:nvPr/>
-        </p:nvSpPr>
-        <p:spPr bwMode="auto">
-          <a:xfrm>
-            <a:off x="1874042" y="687328"/>
-            <a:ext cx="8443916" cy="5816977"/>
-          </a:xfrm>
-          <a:prstGeom prst="rect">
-            <a:avLst/>
-          </a:prstGeom>
-          <a:noFill/>
-          <a:ln w="9525">
-            <a:noFill/>
-            <a:miter lim="800000"/>
-            <a:headEnd/>
-            <a:tailEnd/>
-          </a:ln>
-          <a:effectLst/>
-        </p:spPr>
-        <p:txBody>
-          <a:bodyPr wrap="square">
-            <a:spAutoFit/>
-          </a:bodyPr>
-          <a:lstStyle/>
-          <a:p>
-            <a:pPr algn="ctr">
-              <a:defRPr/>
-            </a:pPr>
-            <a:r>
-              <a:rPr lang="en-US" sz="6000" b="1" dirty="0">
-                <a:solidFill>
-                  <a:srgbClr val="FFFFFF"/>
-                </a:solidFill>
-                <a:latin typeface="Avenir"/>
-                <a:cs typeface="Avenir"/>
-              </a:rPr>
-              <a:t>class norms</a:t>
-            </a:r>
-          </a:p>
-          <a:p>
-            <a:pPr algn="ctr">
-              <a:defRPr/>
-            </a:pPr>
-            <a:endParaRPr lang="en-US" sz="3000" dirty="0">
-              <a:solidFill>
-                <a:srgbClr val="FFFFFF"/>
-              </a:solidFill>
-              <a:latin typeface="Avenir"/>
-              <a:cs typeface="Avenir"/>
-            </a:endParaRPr>
-          </a:p>
-          <a:p>
-            <a:pPr marL="571500" indent="-571500">
-              <a:buFont typeface="Arial" panose="020B0604020202020204" pitchFamily="34" charset="0"/>
-              <a:buChar char="•"/>
-              <a:defRPr/>
-            </a:pPr>
-            <a:r>
-              <a:rPr lang="en-US" sz="4000" dirty="0">
-                <a:solidFill>
-                  <a:srgbClr val="FFFFFF"/>
-                </a:solidFill>
-                <a:latin typeface="Avenir"/>
-                <a:cs typeface="Avenir"/>
-              </a:rPr>
-              <a:t>growth mindset</a:t>
-            </a:r>
-          </a:p>
-          <a:p>
-            <a:pPr marL="571500" indent="-571500">
-              <a:buFont typeface="Arial" panose="020B0604020202020204" pitchFamily="34" charset="0"/>
-              <a:buChar char="•"/>
-              <a:defRPr/>
-            </a:pPr>
-            <a:r>
-              <a:rPr lang="en-US" sz="4000" dirty="0">
-                <a:solidFill>
-                  <a:srgbClr val="FFFFFF"/>
-                </a:solidFill>
-                <a:latin typeface="Avenir"/>
-                <a:cs typeface="Avenir"/>
-              </a:rPr>
-              <a:t>respect and support one another</a:t>
-            </a:r>
-          </a:p>
-          <a:p>
-            <a:pPr marL="571500" indent="-571500">
-              <a:buFont typeface="Arial" panose="020B0604020202020204" pitchFamily="34" charset="0"/>
-              <a:buChar char="•"/>
-              <a:defRPr/>
-            </a:pPr>
-            <a:r>
-              <a:rPr lang="en-US" sz="4000" dirty="0">
-                <a:solidFill>
-                  <a:srgbClr val="FFFFFF"/>
-                </a:solidFill>
-                <a:latin typeface="Avenir"/>
-                <a:cs typeface="Avenir"/>
-              </a:rPr>
-              <a:t>actively listen</a:t>
-            </a:r>
-          </a:p>
-          <a:p>
-            <a:pPr marL="571500" indent="-571500">
-              <a:buFont typeface="Arial" panose="020B0604020202020204" pitchFamily="34" charset="0"/>
-              <a:buChar char="•"/>
-              <a:defRPr/>
-            </a:pPr>
-            <a:r>
-              <a:rPr lang="en-US" sz="4000" dirty="0">
-                <a:solidFill>
-                  <a:srgbClr val="FFFFFF"/>
-                </a:solidFill>
-                <a:latin typeface="Avenir"/>
-                <a:cs typeface="Avenir"/>
-              </a:rPr>
-              <a:t>contribute</a:t>
-            </a:r>
-          </a:p>
-          <a:p>
-            <a:pPr marL="571500" indent="-571500">
-              <a:buFont typeface="Arial" panose="020B0604020202020204" pitchFamily="34" charset="0"/>
-              <a:buChar char="•"/>
-              <a:defRPr/>
-            </a:pPr>
-            <a:r>
-              <a:rPr lang="en-US" sz="4000" dirty="0">
-                <a:solidFill>
-                  <a:srgbClr val="FFFFFF"/>
-                </a:solidFill>
-                <a:latin typeface="Avenir"/>
-                <a:cs typeface="Avenir"/>
-              </a:rPr>
-              <a:t>ask questions</a:t>
-            </a:r>
-          </a:p>
-          <a:p>
-            <a:pPr marL="571500" indent="-571500">
-              <a:buFont typeface="Arial" panose="020B0604020202020204" pitchFamily="34" charset="0"/>
-              <a:buChar char="•"/>
-              <a:defRPr/>
-            </a:pPr>
-            <a:r>
-              <a:rPr lang="en-US" sz="4000" dirty="0">
-                <a:solidFill>
-                  <a:srgbClr val="FFFFFF"/>
-                </a:solidFill>
-                <a:latin typeface="Avenir"/>
-                <a:cs typeface="Avenir"/>
-              </a:rPr>
-              <a:t>monitor air time</a:t>
-            </a:r>
-          </a:p>
-          <a:p>
-            <a:pPr algn="ctr">
-              <a:defRPr/>
-            </a:pPr>
-            <a:endParaRPr lang="en-US" sz="3200" dirty="0">
-              <a:solidFill>
-                <a:srgbClr val="FFFFFF"/>
-              </a:solidFill>
-              <a:latin typeface="Avenir"/>
-              <a:cs typeface="Avenir"/>
-            </a:endParaRPr>
-          </a:p>
-        </p:txBody>
-      </p:sp>
-    </p:spTree>
-    <p:extLst>
-      <p:ext uri="{BB962C8B-B14F-4D97-AF65-F5344CB8AC3E}">
-        <p14:creationId xmlns:p14="http://schemas.microsoft.com/office/powerpoint/2010/main" val="2389094736"/>
-      </p:ext>
-    </p:extLst>
-  </p:cSld>
-  <p:clrMapOvr>
-    <a:masterClrMapping/>
-  </p:clrMapOvr>
-</p:sld>
-</file>
-
-<file path=ppt/slides/slide9.xml><?xml version="1.0" encoding="utf-8"?>
-<p:sld xmlns:a="http://schemas.openxmlformats.org/drawingml/2006/main" xmlns:r="http://schemas.openxmlformats.org/officeDocument/2006/relationships" xmlns:p="http://schemas.openxmlformats.org/presentationml/2006/main">
-  <p:cSld>
-    <p:bg>
-      <p:bgPr>
-        <a:solidFill>
-          <a:schemeClr val="tx1"/>
-        </a:solidFill>
-        <a:effectLst/>
-      </p:bgPr>
-    </p:bg>
-    <p:spTree>
-      <p:nvGrpSpPr>
-        <p:cNvPr id="1" name=""/>
-        <p:cNvGrpSpPr/>
-        <p:nvPr/>
-      </p:nvGrpSpPr>
-      <p:grpSpPr>
-        <a:xfrm>
-          <a:off x="0" y="0"/>
-          <a:ext cx="0" cy="0"/>
-          <a:chOff x="0" y="0"/>
-          <a:chExt cx="0" cy="0"/>
-        </a:xfrm>
-      </p:grpSpPr>
-      <p:sp>
-        <p:nvSpPr>
           <p:cNvPr id="15361" name="Text Box 3"/>
           <p:cNvSpPr txBox="1">
             <a:spLocks noChangeArrowheads="1"/>
@@ -8710,14 +8209,14 @@
           </a:ln>
           <a:extLst>
             <a:ext uri="{909E8E84-426E-40dd-AFC4-6F175D3DCCD1}">
-              <a14:hiddenFill xmlns="" xmlns:a14="http://schemas.microsoft.com/office/drawing/2010/main">
+              <a14:hiddenFill xmlns:a14="http://schemas.microsoft.com/office/drawing/2010/main" xmlns="">
                 <a:solidFill>
                   <a:srgbClr val="FFFFFF"/>
                 </a:solidFill>
               </a14:hiddenFill>
             </a:ext>
             <a:ext uri="{91240B29-F687-4f45-9708-019B960494DF}">
-              <a14:hiddenLine xmlns="" xmlns:a14="http://schemas.microsoft.com/office/drawing/2010/main" w="9525">
+              <a14:hiddenLine xmlns:a14="http://schemas.microsoft.com/office/drawing/2010/main" xmlns="" w="9525">
                 <a:solidFill>
                   <a:srgbClr val="000000"/>
                 </a:solidFill>
@@ -8893,14 +8392,14 @@
           </a:ln>
           <a:extLst>
             <a:ext uri="{909E8E84-426E-40dd-AFC4-6F175D3DCCD1}">
-              <a14:hiddenFill xmlns="" xmlns:a14="http://schemas.microsoft.com/office/drawing/2010/main">
+              <a14:hiddenFill xmlns:a14="http://schemas.microsoft.com/office/drawing/2010/main" xmlns="">
                 <a:solidFill>
                   <a:srgbClr val="FFFFFF"/>
                 </a:solidFill>
               </a14:hiddenFill>
             </a:ext>
             <a:ext uri="{91240B29-F687-4f45-9708-019B960494DF}">
-              <a14:hiddenLine xmlns="" xmlns:a14="http://schemas.microsoft.com/office/drawing/2010/main" w="9525">
+              <a14:hiddenLine xmlns:a14="http://schemas.microsoft.com/office/drawing/2010/main" xmlns="" w="9525">
                 <a:solidFill>
                   <a:srgbClr val="000000"/>
                 </a:solidFill>
@@ -8934,14 +8433,14 @@
           </a:ln>
           <a:extLst>
             <a:ext uri="{909E8E84-426E-40dd-AFC4-6F175D3DCCD1}">
-              <a14:hiddenFill xmlns="" xmlns:a14="http://schemas.microsoft.com/office/drawing/2010/main">
+              <a14:hiddenFill xmlns:a14="http://schemas.microsoft.com/office/drawing/2010/main" xmlns="">
                 <a:solidFill>
                   <a:srgbClr val="FFFFFF"/>
                 </a:solidFill>
               </a14:hiddenFill>
             </a:ext>
             <a:ext uri="{91240B29-F687-4f45-9708-019B960494DF}">
-              <a14:hiddenLine xmlns="" xmlns:a14="http://schemas.microsoft.com/office/drawing/2010/main" w="9525">
+              <a14:hiddenLine xmlns:a14="http://schemas.microsoft.com/office/drawing/2010/main" xmlns="" w="9525">
                 <a:solidFill>
                   <a:srgbClr val="000000"/>
                 </a:solidFill>
@@ -8976,6 +8475,116 @@
     <p:extLst>
       <p:ext uri="{BB962C8B-B14F-4D97-AF65-F5344CB8AC3E}">
         <p14:creationId xmlns:p14="http://schemas.microsoft.com/office/powerpoint/2010/main" val="1198608017"/>
+      </p:ext>
+    </p:extLst>
+  </p:cSld>
+  <p:clrMapOvr>
+    <a:masterClrMapping/>
+  </p:clrMapOvr>
+</p:sld>
+</file>
+
+<file path=ppt/slides/slide9.xml><?xml version="1.0" encoding="utf-8"?>
+<p:sld xmlns:a="http://schemas.openxmlformats.org/drawingml/2006/main" xmlns:r="http://schemas.openxmlformats.org/officeDocument/2006/relationships" xmlns:p="http://schemas.openxmlformats.org/presentationml/2006/main">
+  <p:cSld>
+    <p:spTree>
+      <p:nvGrpSpPr>
+        <p:cNvPr id="1" name=""/>
+        <p:cNvGrpSpPr/>
+        <p:nvPr/>
+      </p:nvGrpSpPr>
+      <p:grpSpPr>
+        <a:xfrm>
+          <a:off x="0" y="0"/>
+          <a:ext cx="0" cy="0"/>
+          <a:chOff x="0" y="0"/>
+          <a:chExt cx="0" cy="0"/>
+        </a:xfrm>
+      </p:grpSpPr>
+      <p:sp>
+        <p:nvSpPr>
+          <p:cNvPr id="2" name="Title 1">
+            <a:extLst>
+              <a:ext uri="{FF2B5EF4-FFF2-40B4-BE49-F238E27FC236}">
+                <a16:creationId xmlns:a16="http://schemas.microsoft.com/office/drawing/2014/main" id="{D46328C8-E57A-4548-E685-7C8547826A9D}"/>
+              </a:ext>
+            </a:extLst>
+          </p:cNvPr>
+          <p:cNvSpPr>
+            <a:spLocks noGrp="1"/>
+          </p:cNvSpPr>
+          <p:nvPr>
+            <p:ph type="ctrTitle"/>
+          </p:nvPr>
+        </p:nvSpPr>
+        <p:spPr/>
+        <p:txBody>
+          <a:bodyPr/>
+          <a:lstStyle/>
+          <a:p>
+            <a:endParaRPr lang="en-US"/>
+          </a:p>
+        </p:txBody>
+      </p:sp>
+      <p:sp>
+        <p:nvSpPr>
+          <p:cNvPr id="3" name="Subtitle 2">
+            <a:extLst>
+              <a:ext uri="{FF2B5EF4-FFF2-40B4-BE49-F238E27FC236}">
+                <a16:creationId xmlns:a16="http://schemas.microsoft.com/office/drawing/2014/main" id="{45A1BAE9-70C8-C269-8AD4-7B4B3D134C13}"/>
+              </a:ext>
+            </a:extLst>
+          </p:cNvPr>
+          <p:cNvSpPr>
+            <a:spLocks noGrp="1"/>
+          </p:cNvSpPr>
+          <p:nvPr>
+            <p:ph type="subTitle" idx="1"/>
+          </p:nvPr>
+        </p:nvSpPr>
+        <p:spPr/>
+        <p:txBody>
+          <a:bodyPr/>
+          <a:lstStyle/>
+          <a:p>
+            <a:endParaRPr lang="en-US"/>
+          </a:p>
+        </p:txBody>
+      </p:sp>
+      <p:pic>
+        <p:nvPicPr>
+          <p:cNvPr id="5" name="slide.url=https://www.polleverywhere.com/multiple_choice_polls/C5Mf4wqoOzxgPhTX3YZyj?state=opened&amp;flow=Default&amp;onscreen=persist">
+            <a:extLst>
+              <a:ext uri="{FF2B5EF4-FFF2-40B4-BE49-F238E27FC236}">
+                <a16:creationId xmlns:a16="http://schemas.microsoft.com/office/drawing/2014/main" id="{C1680DC4-93E8-614B-054E-9D7DCD24A5C6}"/>
+              </a:ext>
+            </a:extLst>
+          </p:cNvPr>
+          <p:cNvPicPr>
+            <a:picLocks/>
+          </p:cNvPicPr>
+          <p:nvPr/>
+        </p:nvPicPr>
+        <p:blipFill>
+          <a:blip r:embed="rId3"/>
+          <a:stretch>
+            <a:fillRect/>
+          </a:stretch>
+        </p:blipFill>
+        <p:spPr>
+          <a:xfrm>
+            <a:off x="63500" y="63500"/>
+            <a:ext cx="12065000" cy="6731000"/>
+          </a:xfrm>
+          <a:prstGeom prst="rect">
+            <a:avLst/>
+          </a:prstGeom>
+        </p:spPr>
+      </p:pic>
+    </p:spTree>
+    <p:extLst>
+      <p:ext uri="{BB962C8B-B14F-4D97-AF65-F5344CB8AC3E}">
+        <p14:creationId xmlns:p14="http://schemas.microsoft.com/office/powerpoint/2010/main" val="1511497431"/>
       </p:ext>
     </p:extLst>
   </p:cSld>

</xml_diff>

<commit_message>
prep for class 3
</commit_message>
<xml_diff>
--- a/docs/lectures/in-class_activities/class_1.pptx
+++ b/docs/lectures/in-class_activities/class_1.pptx
@@ -2232,16 +2232,56 @@
           <a:lstStyle/>
           <a:p>
             <a:r>
-              <a:rPr lang="en-US"/>
+              <a:rPr lang="en-US" dirty="0"/>
               <a:t>Do not modify the notes in this section to avoid tampering with the Poll Everywhere activity.
-More info at polleverywhere.com/support
+More info at </a:t>
+            </a:r>
+            <a:r>
+              <a:rPr lang="en-US" dirty="0" err="1"/>
+              <a:t>polleverywhere.com</a:t>
+            </a:r>
+            <a:r>
+              <a:rPr lang="en-US" dirty="0"/>
+              <a:t>/support
 Have you watched today's assigned video lectures on the course website?</a:t>
             </a:r>
           </a:p>
           <a:p>
             <a:r>
-              <a:rPr lang="en-US"/>
-              <a:t>https://www.polleverywhere.com/multiple_choice_polls/C5Mf4wqoOzxgPhTX3YZyj?state=opened&amp;flow=Default&amp;onscreen=persist</a:t>
+              <a:rPr lang="en-US" dirty="0"/>
+              <a:t>https://</a:t>
+            </a:r>
+            <a:r>
+              <a:rPr lang="en-US" dirty="0" err="1"/>
+              <a:t>www.polleverywhere.com</a:t>
+            </a:r>
+            <a:r>
+              <a:rPr lang="en-US" dirty="0"/>
+              <a:t>/</a:t>
+            </a:r>
+            <a:r>
+              <a:rPr lang="en-US" dirty="0" err="1"/>
+              <a:t>multiple_choice_polls</a:t>
+            </a:r>
+            <a:r>
+              <a:rPr lang="en-US" dirty="0"/>
+              <a:t>/C5Mf4wqoOzxgPhTX3YZyj?state=</a:t>
+            </a:r>
+            <a:r>
+              <a:rPr lang="en-US" dirty="0" err="1"/>
+              <a:t>opened&amp;flow</a:t>
+            </a:r>
+            <a:r>
+              <a:rPr lang="en-US" dirty="0"/>
+              <a:t>=</a:t>
+            </a:r>
+            <a:r>
+              <a:rPr lang="en-US" dirty="0" err="1"/>
+              <a:t>Default&amp;onscreen</a:t>
+            </a:r>
+            <a:r>
+              <a:rPr lang="en-US" dirty="0"/>
+              <a:t>=persist</a:t>
             </a:r>
           </a:p>
         </p:txBody>

</xml_diff>